<commit_message>
chore(deploy): wire AI service url to https://orca-aiservices.onrender.com
</commit_message>
<xml_diff>
--- a/SIH26176.pptx
+++ b/SIH26176.pptx
@@ -643,7 +643,7 @@
           <a:p>
             <a:fld id="{9BE7632D-5D22-4C77-A663-2CBEB70F7510}" type="datetimeFigureOut">
               <a:rPr lang="en-IN" smtClean="0"/>
-              <a:t>25-09-2026</a:t>
+              <a:t>29-09-2026</a:t>
             </a:fld>
             <a:endParaRPr lang="en-IN" dirty="0"/>
           </a:p>
@@ -1455,7 +1455,7 @@
             <a:fld id="{1D8BD707-D9CF-40AE-B4C6-C98DA3205C09}" type="datetimeFigureOut">
               <a:rPr lang="en-US" smtClean="0"/>
               <a:pPr/>
-              <a:t>9/25/2026</a:t>
+              <a:t>9/29/2026</a:t>
             </a:fld>
             <a:endParaRPr lang="en-US" dirty="0"/>
           </a:p>
@@ -1620,7 +1620,7 @@
             <a:fld id="{1D8BD707-D9CF-40AE-B4C6-C98DA3205C09}" type="datetimeFigureOut">
               <a:rPr lang="en-US" smtClean="0"/>
               <a:pPr/>
-              <a:t>9/25/2026</a:t>
+              <a:t>9/29/2026</a:t>
             </a:fld>
             <a:endParaRPr lang="en-US" dirty="0"/>
           </a:p>
@@ -1795,7 +1795,7 @@
             <a:fld id="{1D8BD707-D9CF-40AE-B4C6-C98DA3205C09}" type="datetimeFigureOut">
               <a:rPr lang="en-US" smtClean="0"/>
               <a:pPr/>
-              <a:t>9/25/2026</a:t>
+              <a:t>9/29/2026</a:t>
             </a:fld>
             <a:endParaRPr lang="en-US" dirty="0"/>
           </a:p>
@@ -1995,7 +1995,7 @@
             <a:fld id="{1D8BD707-D9CF-40AE-B4C6-C98DA3205C09}" type="datetimeFigureOut">
               <a:rPr lang="en-US" smtClean="0"/>
               <a:pPr/>
-              <a:t>9/25/2026</a:t>
+              <a:t>9/29/2026</a:t>
             </a:fld>
             <a:endParaRPr lang="en-US" dirty="0"/>
           </a:p>
@@ -2237,7 +2237,7 @@
             <a:fld id="{1D8BD707-D9CF-40AE-B4C6-C98DA3205C09}" type="datetimeFigureOut">
               <a:rPr lang="en-US" smtClean="0"/>
               <a:pPr/>
-              <a:t>9/25/2026</a:t>
+              <a:t>9/29/2026</a:t>
             </a:fld>
             <a:endParaRPr lang="en-US" dirty="0"/>
           </a:p>
@@ -2519,7 +2519,7 @@
             <a:fld id="{1D8BD707-D9CF-40AE-B4C6-C98DA3205C09}" type="datetimeFigureOut">
               <a:rPr lang="en-US" smtClean="0"/>
               <a:pPr/>
-              <a:t>9/25/2026</a:t>
+              <a:t>9/29/2026</a:t>
             </a:fld>
             <a:endParaRPr lang="en-US" dirty="0"/>
           </a:p>
@@ -2935,7 +2935,7 @@
             <a:fld id="{1D8BD707-D9CF-40AE-B4C6-C98DA3205C09}" type="datetimeFigureOut">
               <a:rPr lang="en-US" smtClean="0"/>
               <a:pPr/>
-              <a:t>9/25/2026</a:t>
+              <a:t>9/29/2026</a:t>
             </a:fld>
             <a:endParaRPr lang="en-US" dirty="0"/>
           </a:p>
@@ -3049,7 +3049,7 @@
             <a:fld id="{1D8BD707-D9CF-40AE-B4C6-C98DA3205C09}" type="datetimeFigureOut">
               <a:rPr lang="en-US" smtClean="0"/>
               <a:pPr/>
-              <a:t>9/25/2026</a:t>
+              <a:t>9/29/2026</a:t>
             </a:fld>
             <a:endParaRPr lang="en-US" dirty="0"/>
           </a:p>
@@ -3141,7 +3141,7 @@
             <a:fld id="{1D8BD707-D9CF-40AE-B4C6-C98DA3205C09}" type="datetimeFigureOut">
               <a:rPr lang="en-US" smtClean="0"/>
               <a:pPr/>
-              <a:t>9/25/2026</a:t>
+              <a:t>9/29/2026</a:t>
             </a:fld>
             <a:endParaRPr lang="en-US" dirty="0"/>
           </a:p>
@@ -3413,7 +3413,7 @@
             <a:fld id="{1D8BD707-D9CF-40AE-B4C6-C98DA3205C09}" type="datetimeFigureOut">
               <a:rPr lang="en-US" smtClean="0"/>
               <a:pPr/>
-              <a:t>9/25/2026</a:t>
+              <a:t>9/29/2026</a:t>
             </a:fld>
             <a:endParaRPr lang="en-US" dirty="0"/>
           </a:p>
@@ -3662,7 +3662,7 @@
             <a:fld id="{1D8BD707-D9CF-40AE-B4C6-C98DA3205C09}" type="datetimeFigureOut">
               <a:rPr lang="en-US" smtClean="0"/>
               <a:pPr/>
-              <a:t>9/25/2026</a:t>
+              <a:t>9/29/2026</a:t>
             </a:fld>
             <a:endParaRPr lang="en-US" dirty="0"/>
           </a:p>
@@ -3870,7 +3870,7 @@
             <a:fld id="{1D8BD707-D9CF-40AE-B4C6-C98DA3205C09}" type="datetimeFigureOut">
               <a:rPr lang="en-US" smtClean="0"/>
               <a:pPr/>
-              <a:t>9/25/2026</a:t>
+              <a:t>9/29/2026</a:t>
             </a:fld>
             <a:endParaRPr lang="en-US" dirty="0"/>
           </a:p>
@@ -4809,7 +4809,7 @@
         </p:nvSpPr>
         <p:spPr>
           <a:xfrm>
-            <a:off x="4363254" y="175271"/>
+            <a:off x="2474379" y="274761"/>
             <a:ext cx="12893040" cy="822960"/>
           </a:xfrm>
           <a:prstGeom prst="rect">
@@ -4823,35 +4823,22 @@
           <a:lstStyle/>
           <a:p>
             <a:r>
-              <a:rPr lang="en-IN" sz="4500" b="1" u="sng" dirty="0">
+              <a:rPr lang="en-US" sz="4000" b="1" u="sng" dirty="0">
                 <a:solidFill>
-                  <a:schemeClr val="tx2">
-                    <a:lumMod val="75000"/>
-                  </a:schemeClr>
+                  <a:schemeClr val="tx2"/>
                 </a:solidFill>
+                <a:latin typeface="Arial" panose="020B0604020202020204" pitchFamily="34" charset="0"/>
+                <a:cs typeface="Arial" panose="020B0604020202020204" pitchFamily="34" charset="0"/>
               </a:rPr>
-              <a:t>SOVEREIGN </a:t>
-            </a:r>
-            <a:r>
-              <a:rPr lang="en-IN" sz="4000" b="1" u="sng" dirty="0">
-                <a:solidFill>
-                  <a:schemeClr val="tx2">
-                    <a:lumMod val="75000"/>
-                  </a:schemeClr>
-                </a:solidFill>
-              </a:rPr>
-              <a:t>ON-PREMISE</a:t>
-            </a:r>
-            <a:r>
-              <a:rPr lang="en-IN" sz="4500" b="1" u="sng" dirty="0">
-                <a:solidFill>
-                  <a:schemeClr val="tx2">
-                    <a:lumMod val="75000"/>
-                  </a:schemeClr>
-                </a:solidFill>
-              </a:rPr>
-              <a:t> AI  WORKBENCH         </a:t>
-            </a:r>
+              <a:t>ORCA / NEERDRISHTI AS THE SOLUTION IDNETITY</a:t>
+            </a:r>
+            <a:endParaRPr lang="en-IN" sz="4000" b="1" u="sng" dirty="0">
+              <a:solidFill>
+                <a:schemeClr val="tx2"/>
+              </a:solidFill>
+              <a:latin typeface="Arial" panose="020B0604020202020204" pitchFamily="34" charset="0"/>
+              <a:cs typeface="Arial" panose="020B0604020202020204" pitchFamily="34" charset="0"/>
+            </a:endParaRPr>
           </a:p>
         </p:txBody>
       </p:sp>
@@ -6230,205 +6217,883 @@
           </a:p>
         </p:txBody>
       </p:sp>
-      <p:pic>
-        <p:nvPicPr>
-          <p:cNvPr id="19" name="Picture 18" descr="MULTI-AGENT&#10;AI SYSTEM&#10;Specialized AI agents">
-            <a:extLst>
-              <a:ext uri="{FF2B5EF4-FFF2-40B4-BE49-F238E27FC236}">
-                <a16:creationId xmlns:a16="http://schemas.microsoft.com/office/drawing/2014/main" id="{36808BF6-D759-3811-E5AA-011E8060DB7B}"/>
-              </a:ext>
-            </a:extLst>
-          </p:cNvPr>
-          <p:cNvPicPr>
-            <a:picLocks noChangeAspect="1"/>
-          </p:cNvPicPr>
-          <p:nvPr/>
-        </p:nvPicPr>
-        <p:blipFill>
-          <a:blip r:embed="rId6"/>
-          <a:stretch>
-            <a:fillRect/>
-          </a:stretch>
-        </p:blipFill>
-        <p:spPr>
-          <a:xfrm>
-            <a:off x="16040028" y="1798769"/>
-            <a:ext cx="2000250" cy="2181225"/>
+      <p:sp>
+        <p:nvSpPr>
+          <p:cNvPr id="15" name="TextBox 14">
+            <a:extLst>
+              <a:ext uri="{FF2B5EF4-FFF2-40B4-BE49-F238E27FC236}">
+                <a16:creationId xmlns:a16="http://schemas.microsoft.com/office/drawing/2014/main" id="{3C4B1F31-1BB9-3F3E-E231-56E5CE422946}"/>
+              </a:ext>
+            </a:extLst>
+          </p:cNvPr>
+          <p:cNvSpPr txBox="1"/>
+          <p:nvPr/>
+        </p:nvSpPr>
+        <p:spPr>
+          <a:xfrm>
+            <a:off x="5521486" y="8177150"/>
+            <a:ext cx="3406201" cy="1200329"/>
           </a:xfrm>
           <a:prstGeom prst="rect">
             <a:avLst/>
           </a:prstGeom>
-        </p:spPr>
-      </p:pic>
-      <p:pic>
-        <p:nvPicPr>
-          <p:cNvPr id="20" name="Picture 19" descr="INPUT DATA&#10;Documents &amp; data">
-            <a:extLst>
-              <a:ext uri="{FF2B5EF4-FFF2-40B4-BE49-F238E27FC236}">
-                <a16:creationId xmlns:a16="http://schemas.microsoft.com/office/drawing/2014/main" id="{EC5A1EAA-B0AD-EC86-4DC3-732220B20934}"/>
-              </a:ext>
-            </a:extLst>
-          </p:cNvPr>
-          <p:cNvPicPr>
-            <a:picLocks noChangeAspect="1"/>
-          </p:cNvPicPr>
-          <p:nvPr/>
-        </p:nvPicPr>
-        <p:blipFill>
-          <a:blip r:embed="rId7"/>
-          <a:stretch>
-            <a:fillRect/>
-          </a:stretch>
-        </p:blipFill>
-        <p:spPr>
-          <a:xfrm>
-            <a:off x="10880113" y="1793091"/>
-            <a:ext cx="2000250" cy="2181225"/>
+          <a:noFill/>
+        </p:spPr>
+        <p:txBody>
+          <a:bodyPr wrap="square" rtlCol="0">
+            <a:spAutoFit/>
+          </a:bodyPr>
+          <a:lstStyle/>
+          <a:p>
+            <a:r>
+              <a:rPr lang="en-IN" sz="2400" dirty="0"/>
+              <a:t>Uses AI to automate data analysis and reduce manual effort.</a:t>
+            </a:r>
+          </a:p>
+        </p:txBody>
+      </p:sp>
+      <p:sp>
+        <p:nvSpPr>
+          <p:cNvPr id="2" name="Shape 1">
+            <a:extLst>
+              <a:ext uri="{FF2B5EF4-FFF2-40B4-BE49-F238E27FC236}">
+                <a16:creationId xmlns:a16="http://schemas.microsoft.com/office/drawing/2014/main" id="{97A00C1E-615A-8E66-6827-D67C6F5F11F9}"/>
+              </a:ext>
+            </a:extLst>
+          </p:cNvPr>
+          <p:cNvSpPr/>
+          <p:nvPr/>
+        </p:nvSpPr>
+        <p:spPr>
+          <a:xfrm>
+            <a:off x="12691886" y="1920240"/>
+            <a:ext cx="2852914" cy="633984"/>
+          </a:xfrm>
+          <a:prstGeom prst="roundRect">
+            <a:avLst>
+              <a:gd name="adj" fmla="val 20000"/>
+            </a:avLst>
+          </a:prstGeom>
+          <a:solidFill>
+            <a:srgbClr val="EAF1F8"/>
+          </a:solidFill>
+          <a:ln w="15875">
+            <a:solidFill>
+              <a:srgbClr val="0B2545"/>
+            </a:solidFill>
+            <a:prstDash val="solid"/>
+          </a:ln>
+        </p:spPr>
+      </p:sp>
+      <p:sp>
+        <p:nvSpPr>
+          <p:cNvPr id="11" name="Text 2">
+            <a:extLst>
+              <a:ext uri="{FF2B5EF4-FFF2-40B4-BE49-F238E27FC236}">
+                <a16:creationId xmlns:a16="http://schemas.microsoft.com/office/drawing/2014/main" id="{7E13E5D5-CAA6-548D-368A-57A6B76D1267}"/>
+              </a:ext>
+            </a:extLst>
+          </p:cNvPr>
+          <p:cNvSpPr txBox="1"/>
+          <p:nvPr/>
+        </p:nvSpPr>
+        <p:spPr>
+          <a:xfrm>
+            <a:off x="12691886" y="1920240"/>
+            <a:ext cx="2852914" cy="633984"/>
           </a:xfrm>
           <a:prstGeom prst="rect">
             <a:avLst/>
           </a:prstGeom>
-        </p:spPr>
-      </p:pic>
-      <p:pic>
-        <p:nvPicPr>
-          <p:cNvPr id="21" name="Picture 20" descr="ONE UNIFIED&#10;PLATFORM&#10;Everything in one place">
-            <a:extLst>
-              <a:ext uri="{FF2B5EF4-FFF2-40B4-BE49-F238E27FC236}">
-                <a16:creationId xmlns:a16="http://schemas.microsoft.com/office/drawing/2014/main" id="{16B1D76F-85DC-DFF1-4127-D2E5A9CA5DC2}"/>
-              </a:ext>
-            </a:extLst>
-          </p:cNvPr>
-          <p:cNvPicPr>
-            <a:picLocks noChangeAspect="1"/>
-          </p:cNvPicPr>
-          <p:nvPr/>
-        </p:nvPicPr>
-        <p:blipFill>
-          <a:blip r:embed="rId8"/>
-          <a:stretch>
-            <a:fillRect/>
-          </a:stretch>
-        </p:blipFill>
-        <p:spPr>
-          <a:xfrm>
-            <a:off x="13524648" y="1793090"/>
-            <a:ext cx="2000250" cy="2181225"/>
+          <a:noFill/>
+          <a:ln/>
+        </p:spPr>
+        <p:txBody>
+          <a:bodyPr wrap="square" lIns="635" tIns="635" rIns="635" bIns="635" rtlCol="0" anchor="ctr"/>
+          <a:lstStyle/>
+          <a:p>
+            <a:pPr marL="0" indent="0" algn="ctr">
+              <a:buNone/>
+            </a:pPr>
+            <a:r>
+              <a:rPr lang="en-US" sz="1400" b="1" dirty="0">
+                <a:solidFill>
+                  <a:srgbClr val="0B2545"/>
+                </a:solidFill>
+                <a:latin typeface="Calibri" pitchFamily="34" charset="0"/>
+                <a:ea typeface="Calibri" pitchFamily="34" charset="-122"/>
+                <a:cs typeface="Calibri" pitchFamily="34" charset="-120"/>
+              </a:rPr>
+              <a:t>USER QUERY</a:t>
+            </a:r>
+            <a:endParaRPr lang="en-US" sz="1400" dirty="0"/>
+          </a:p>
+        </p:txBody>
+      </p:sp>
+      <p:sp>
+        <p:nvSpPr>
+          <p:cNvPr id="17" name="Shape 3">
+            <a:extLst>
+              <a:ext uri="{FF2B5EF4-FFF2-40B4-BE49-F238E27FC236}">
+                <a16:creationId xmlns:a16="http://schemas.microsoft.com/office/drawing/2014/main" id="{4289792C-21B6-8035-12D7-AC972F804A1A}"/>
+              </a:ext>
+            </a:extLst>
+          </p:cNvPr>
+          <p:cNvSpPr/>
+          <p:nvPr/>
+        </p:nvSpPr>
+        <p:spPr>
+          <a:xfrm>
+            <a:off x="14211456" y="2554224"/>
+            <a:ext cx="0" cy="379476"/>
+          </a:xfrm>
+          <a:prstGeom prst="line">
+            <a:avLst/>
+          </a:prstGeom>
+          <a:ln>
+            <a:tailEnd type="triangle"/>
+          </a:ln>
+        </p:spPr>
+        <p:style>
+          <a:lnRef idx="3">
+            <a:schemeClr val="dk1"/>
+          </a:lnRef>
+          <a:fillRef idx="0">
+            <a:schemeClr val="dk1"/>
+          </a:fillRef>
+          <a:effectRef idx="2">
+            <a:schemeClr val="dk1"/>
+          </a:effectRef>
+          <a:fontRef idx="minor">
+            <a:schemeClr val="tx1"/>
+          </a:fontRef>
+        </p:style>
+      </p:sp>
+      <p:sp>
+        <p:nvSpPr>
+          <p:cNvPr id="18" name="Shape 4">
+            <a:extLst>
+              <a:ext uri="{FF2B5EF4-FFF2-40B4-BE49-F238E27FC236}">
+                <a16:creationId xmlns:a16="http://schemas.microsoft.com/office/drawing/2014/main" id="{6E0600C4-3AEA-25AF-3914-9705101284BA}"/>
+              </a:ext>
+            </a:extLst>
+          </p:cNvPr>
+          <p:cNvSpPr/>
+          <p:nvPr/>
+        </p:nvSpPr>
+        <p:spPr>
+          <a:xfrm>
+            <a:off x="12537010" y="2933700"/>
+            <a:ext cx="3423497" cy="713232"/>
+          </a:xfrm>
+          <a:prstGeom prst="roundRect">
+            <a:avLst>
+              <a:gd name="adj" fmla="val 17778"/>
+            </a:avLst>
+          </a:prstGeom>
+          <a:solidFill>
+            <a:srgbClr val="0B2545"/>
+          </a:solidFill>
+          <a:ln w="15875">
+            <a:solidFill>
+              <a:srgbClr val="0B2545"/>
+            </a:solidFill>
+            <a:prstDash val="solid"/>
+          </a:ln>
+        </p:spPr>
+      </p:sp>
+      <p:sp>
+        <p:nvSpPr>
+          <p:cNvPr id="25" name="Text 5">
+            <a:extLst>
+              <a:ext uri="{FF2B5EF4-FFF2-40B4-BE49-F238E27FC236}">
+                <a16:creationId xmlns:a16="http://schemas.microsoft.com/office/drawing/2014/main" id="{48F7CD96-1614-AF72-F310-AE461BFAF295}"/>
+              </a:ext>
+            </a:extLst>
+          </p:cNvPr>
+          <p:cNvSpPr txBox="1"/>
+          <p:nvPr/>
+        </p:nvSpPr>
+        <p:spPr>
+          <a:xfrm>
+            <a:off x="12496800" y="2978627"/>
+            <a:ext cx="3423497" cy="713232"/>
           </a:xfrm>
           <a:prstGeom prst="rect">
             <a:avLst/>
           </a:prstGeom>
-        </p:spPr>
-      </p:pic>
-      <p:pic>
-        <p:nvPicPr>
-          <p:cNvPr id="22" name="Picture 21" descr="AI ANALYSIS &amp;&#10;SMART EXTRACTION&#10;Process &amp; extract insights">
-            <a:extLst>
-              <a:ext uri="{FF2B5EF4-FFF2-40B4-BE49-F238E27FC236}">
-                <a16:creationId xmlns:a16="http://schemas.microsoft.com/office/drawing/2014/main" id="{C5FA91BD-4CEC-880C-561F-683BE7EE82D2}"/>
-              </a:ext>
-            </a:extLst>
-          </p:cNvPr>
-          <p:cNvPicPr>
-            <a:picLocks noChangeAspect="1"/>
-          </p:cNvPicPr>
-          <p:nvPr/>
-        </p:nvPicPr>
-        <p:blipFill>
-          <a:blip r:embed="rId9"/>
-          <a:stretch>
-            <a:fillRect/>
-          </a:stretch>
-        </p:blipFill>
-        <p:spPr>
-          <a:xfrm>
-            <a:off x="16051271" y="4791683"/>
-            <a:ext cx="2000250" cy="2181225"/>
+          <a:noFill/>
+          <a:ln/>
+        </p:spPr>
+        <p:txBody>
+          <a:bodyPr wrap="square" lIns="635" tIns="635" rIns="635" bIns="635" rtlCol="0" anchor="ctr"/>
+          <a:lstStyle/>
+          <a:p>
+            <a:pPr marL="0" indent="0" algn="ctr">
+              <a:buNone/>
+            </a:pPr>
+            <a:r>
+              <a:rPr lang="en-US" sz="1500" b="1" dirty="0">
+                <a:solidFill>
+                  <a:srgbClr val="FFFFFF"/>
+                </a:solidFill>
+                <a:latin typeface="Calibri" pitchFamily="34" charset="0"/>
+                <a:ea typeface="Calibri" pitchFamily="34" charset="-122"/>
+                <a:cs typeface="Calibri" pitchFamily="34" charset="-120"/>
+              </a:rPr>
+              <a:t>  AGENT ORCHESTRATOR</a:t>
+            </a:r>
+            <a:endParaRPr lang="en-US" sz="1500" dirty="0"/>
+          </a:p>
+        </p:txBody>
+      </p:sp>
+      <p:sp>
+        <p:nvSpPr>
+          <p:cNvPr id="33" name="Shape 11">
+            <a:extLst>
+              <a:ext uri="{FF2B5EF4-FFF2-40B4-BE49-F238E27FC236}">
+                <a16:creationId xmlns:a16="http://schemas.microsoft.com/office/drawing/2014/main" id="{3B800BB7-3540-CA4D-EF6A-4293286CC02A}"/>
+              </a:ext>
+            </a:extLst>
+          </p:cNvPr>
+          <p:cNvSpPr/>
+          <p:nvPr/>
+        </p:nvSpPr>
+        <p:spPr>
+          <a:xfrm>
+            <a:off x="10738343" y="4305300"/>
+            <a:ext cx="2075789" cy="659282"/>
+          </a:xfrm>
+          <a:prstGeom prst="roundRect">
+            <a:avLst>
+              <a:gd name="adj" fmla="val 11429"/>
+            </a:avLst>
+          </a:prstGeom>
+          <a:solidFill>
+            <a:srgbClr val="E0F2F1"/>
+          </a:solidFill>
+          <a:ln w="15875">
+            <a:solidFill>
+              <a:srgbClr val="0E7C7B"/>
+            </a:solidFill>
+            <a:prstDash val="solid"/>
+          </a:ln>
+        </p:spPr>
+      </p:sp>
+      <p:sp>
+        <p:nvSpPr>
+          <p:cNvPr id="35" name="Text 12">
+            <a:extLst>
+              <a:ext uri="{FF2B5EF4-FFF2-40B4-BE49-F238E27FC236}">
+                <a16:creationId xmlns:a16="http://schemas.microsoft.com/office/drawing/2014/main" id="{00757D74-A92E-2F32-1260-61B47AD0F81B}"/>
+              </a:ext>
+            </a:extLst>
+          </p:cNvPr>
+          <p:cNvSpPr txBox="1"/>
+          <p:nvPr/>
+        </p:nvSpPr>
+        <p:spPr>
+          <a:xfrm>
+            <a:off x="10738343" y="4305300"/>
+            <a:ext cx="2075789" cy="659282"/>
           </a:xfrm>
           <a:prstGeom prst="rect">
             <a:avLst/>
           </a:prstGeom>
-        </p:spPr>
-      </p:pic>
-      <p:pic>
-        <p:nvPicPr>
-          <p:cNvPr id="23" name="Picture 22" descr="INTERACTIVE&#10;DASHBOARD&#10;Simple visual results">
-            <a:extLst>
-              <a:ext uri="{FF2B5EF4-FFF2-40B4-BE49-F238E27FC236}">
-                <a16:creationId xmlns:a16="http://schemas.microsoft.com/office/drawing/2014/main" id="{74E3EFD4-3EA3-D050-D608-0B2780669358}"/>
-              </a:ext>
-            </a:extLst>
-          </p:cNvPr>
-          <p:cNvPicPr>
-            <a:picLocks noChangeAspect="1"/>
-          </p:cNvPicPr>
-          <p:nvPr/>
-        </p:nvPicPr>
-        <p:blipFill>
-          <a:blip r:embed="rId10"/>
-          <a:stretch>
-            <a:fillRect/>
-          </a:stretch>
-        </p:blipFill>
-        <p:spPr>
-          <a:xfrm>
-            <a:off x="13593574" y="4791075"/>
-            <a:ext cx="2000250" cy="2181225"/>
+          <a:noFill/>
+          <a:ln/>
+        </p:spPr>
+        <p:txBody>
+          <a:bodyPr wrap="square" lIns="635" tIns="635" rIns="635" bIns="635" rtlCol="0" anchor="ctr"/>
+          <a:lstStyle/>
+          <a:p>
+            <a:pPr marL="0" indent="0" algn="ctr">
+              <a:buNone/>
+            </a:pPr>
+            <a:r>
+              <a:rPr lang="en-US" sz="1500" b="1" dirty="0">
+                <a:solidFill>
+                  <a:srgbClr val="0B2545"/>
+                </a:solidFill>
+                <a:latin typeface="Calibri" pitchFamily="34" charset="0"/>
+                <a:ea typeface="Calibri" pitchFamily="34" charset="-122"/>
+                <a:cs typeface="Calibri" pitchFamily="34" charset="-120"/>
+              </a:rPr>
+              <a:t>Ocean / PFZ Agent</a:t>
+            </a:r>
+            <a:endParaRPr lang="en-US" sz="1500" dirty="0"/>
+          </a:p>
+        </p:txBody>
+      </p:sp>
+      <p:sp>
+        <p:nvSpPr>
+          <p:cNvPr id="37" name="Shape 13">
+            <a:extLst>
+              <a:ext uri="{FF2B5EF4-FFF2-40B4-BE49-F238E27FC236}">
+                <a16:creationId xmlns:a16="http://schemas.microsoft.com/office/drawing/2014/main" id="{9EFF2A50-FCFD-563F-D5AA-6BE9F92CC0E0}"/>
+              </a:ext>
+            </a:extLst>
+          </p:cNvPr>
+          <p:cNvSpPr/>
+          <p:nvPr/>
+        </p:nvSpPr>
+        <p:spPr>
+          <a:xfrm>
+            <a:off x="13298663" y="4305300"/>
+            <a:ext cx="2075789" cy="659282"/>
+          </a:xfrm>
+          <a:prstGeom prst="roundRect">
+            <a:avLst>
+              <a:gd name="adj" fmla="val 11429"/>
+            </a:avLst>
+          </a:prstGeom>
+          <a:solidFill>
+            <a:srgbClr val="E0F2F1"/>
+          </a:solidFill>
+          <a:ln w="15875">
+            <a:solidFill>
+              <a:srgbClr val="0E7C7B"/>
+            </a:solidFill>
+            <a:prstDash val="solid"/>
+          </a:ln>
+        </p:spPr>
+      </p:sp>
+      <p:sp>
+        <p:nvSpPr>
+          <p:cNvPr id="38" name="Text 14">
+            <a:extLst>
+              <a:ext uri="{FF2B5EF4-FFF2-40B4-BE49-F238E27FC236}">
+                <a16:creationId xmlns:a16="http://schemas.microsoft.com/office/drawing/2014/main" id="{B605FB30-4AD9-2BFE-C887-4AE3F7CE1699}"/>
+              </a:ext>
+            </a:extLst>
+          </p:cNvPr>
+          <p:cNvSpPr txBox="1"/>
+          <p:nvPr/>
+        </p:nvSpPr>
+        <p:spPr>
+          <a:xfrm>
+            <a:off x="13298663" y="4305300"/>
+            <a:ext cx="2075789" cy="659282"/>
           </a:xfrm>
           <a:prstGeom prst="rect">
             <a:avLst/>
           </a:prstGeom>
-        </p:spPr>
-      </p:pic>
-      <p:pic>
-        <p:nvPicPr>
-          <p:cNvPr id="24" name="Picture 23" descr="DECISION&#10;SUPPORT&#10;Faster informed action">
-            <a:extLst>
-              <a:ext uri="{FF2B5EF4-FFF2-40B4-BE49-F238E27FC236}">
-                <a16:creationId xmlns:a16="http://schemas.microsoft.com/office/drawing/2014/main" id="{1E4324AD-1132-31B4-B66A-055224BA4D84}"/>
-              </a:ext>
-            </a:extLst>
-          </p:cNvPr>
-          <p:cNvPicPr>
-            <a:picLocks noChangeAspect="1"/>
-          </p:cNvPicPr>
-          <p:nvPr/>
-        </p:nvPicPr>
-        <p:blipFill>
-          <a:blip r:embed="rId11"/>
-          <a:stretch>
-            <a:fillRect/>
-          </a:stretch>
-        </p:blipFill>
-        <p:spPr>
-          <a:xfrm>
-            <a:off x="10925787" y="4791075"/>
-            <a:ext cx="2000250" cy="2181225"/>
+          <a:noFill/>
+          <a:ln/>
+        </p:spPr>
+        <p:txBody>
+          <a:bodyPr wrap="square" lIns="635" tIns="635" rIns="635" bIns="635" rtlCol="0" anchor="ctr"/>
+          <a:lstStyle/>
+          <a:p>
+            <a:pPr marL="0" indent="0" algn="ctr">
+              <a:buNone/>
+            </a:pPr>
+            <a:r>
+              <a:rPr lang="en-US" sz="1500" b="1" dirty="0">
+                <a:solidFill>
+                  <a:srgbClr val="0B2545"/>
+                </a:solidFill>
+                <a:latin typeface="Calibri" pitchFamily="34" charset="0"/>
+                <a:ea typeface="Calibri" pitchFamily="34" charset="-122"/>
+                <a:cs typeface="Calibri" pitchFamily="34" charset="-120"/>
+              </a:rPr>
+              <a:t>Weather Agent</a:t>
+            </a:r>
+            <a:endParaRPr lang="en-US" sz="1500" dirty="0"/>
+          </a:p>
+        </p:txBody>
+      </p:sp>
+      <p:sp>
+        <p:nvSpPr>
+          <p:cNvPr id="39" name="Shape 15">
+            <a:extLst>
+              <a:ext uri="{FF2B5EF4-FFF2-40B4-BE49-F238E27FC236}">
+                <a16:creationId xmlns:a16="http://schemas.microsoft.com/office/drawing/2014/main" id="{2433D1A2-E362-C0D1-1A7E-FB2085001DAC}"/>
+              </a:ext>
+            </a:extLst>
+          </p:cNvPr>
+          <p:cNvSpPr/>
+          <p:nvPr/>
+        </p:nvSpPr>
+        <p:spPr>
+          <a:xfrm>
+            <a:off x="15858983" y="4305300"/>
+            <a:ext cx="2075789" cy="659282"/>
+          </a:xfrm>
+          <a:prstGeom prst="roundRect">
+            <a:avLst>
+              <a:gd name="adj" fmla="val 11429"/>
+            </a:avLst>
+          </a:prstGeom>
+          <a:solidFill>
+            <a:srgbClr val="E0F2F1"/>
+          </a:solidFill>
+          <a:ln w="15875">
+            <a:solidFill>
+              <a:srgbClr val="0E7C7B"/>
+            </a:solidFill>
+            <a:prstDash val="solid"/>
+          </a:ln>
+        </p:spPr>
+      </p:sp>
+      <p:sp>
+        <p:nvSpPr>
+          <p:cNvPr id="40" name="Text 16">
+            <a:extLst>
+              <a:ext uri="{FF2B5EF4-FFF2-40B4-BE49-F238E27FC236}">
+                <a16:creationId xmlns:a16="http://schemas.microsoft.com/office/drawing/2014/main" id="{FB2463EA-EA8A-C858-5AA4-FC321D9CC062}"/>
+              </a:ext>
+            </a:extLst>
+          </p:cNvPr>
+          <p:cNvSpPr txBox="1"/>
+          <p:nvPr/>
+        </p:nvSpPr>
+        <p:spPr>
+          <a:xfrm>
+            <a:off x="15858983" y="4305300"/>
+            <a:ext cx="2075789" cy="659282"/>
           </a:xfrm>
           <a:prstGeom prst="rect">
             <a:avLst/>
           </a:prstGeom>
-        </p:spPr>
-      </p:pic>
+          <a:noFill/>
+          <a:ln/>
+        </p:spPr>
+        <p:txBody>
+          <a:bodyPr wrap="square" lIns="635" tIns="635" rIns="635" bIns="635" rtlCol="0" anchor="ctr"/>
+          <a:lstStyle/>
+          <a:p>
+            <a:pPr marL="0" indent="0" algn="ctr">
+              <a:buNone/>
+            </a:pPr>
+            <a:r>
+              <a:rPr lang="en-US" sz="1500" b="1" dirty="0">
+                <a:solidFill>
+                  <a:srgbClr val="0B2545"/>
+                </a:solidFill>
+                <a:latin typeface="Calibri" pitchFamily="34" charset="0"/>
+                <a:ea typeface="Calibri" pitchFamily="34" charset="-122"/>
+                <a:cs typeface="Calibri" pitchFamily="34" charset="-120"/>
+              </a:rPr>
+              <a:t>GIS Agent</a:t>
+            </a:r>
+            <a:endParaRPr lang="en-US" sz="1500" dirty="0"/>
+          </a:p>
+        </p:txBody>
+      </p:sp>
+      <p:sp>
+        <p:nvSpPr>
+          <p:cNvPr id="47" name="Shape 22">
+            <a:extLst>
+              <a:ext uri="{FF2B5EF4-FFF2-40B4-BE49-F238E27FC236}">
+                <a16:creationId xmlns:a16="http://schemas.microsoft.com/office/drawing/2014/main" id="{BD44F366-1B52-80D6-5D26-635F4FE27C83}"/>
+              </a:ext>
+            </a:extLst>
+          </p:cNvPr>
+          <p:cNvSpPr/>
+          <p:nvPr/>
+        </p:nvSpPr>
+        <p:spPr>
+          <a:xfrm>
+            <a:off x="9982199" y="5878068"/>
+            <a:ext cx="1237489" cy="941832"/>
+          </a:xfrm>
+          <a:prstGeom prst="roundRect">
+            <a:avLst>
+              <a:gd name="adj" fmla="val 8000"/>
+            </a:avLst>
+          </a:prstGeom>
+          <a:solidFill>
+            <a:srgbClr val="EAF1F8"/>
+          </a:solidFill>
+          <a:ln w="15875">
+            <a:solidFill>
+              <a:srgbClr val="0B2545"/>
+            </a:solidFill>
+            <a:prstDash val="solid"/>
+          </a:ln>
+        </p:spPr>
+      </p:sp>
+      <p:sp>
+        <p:nvSpPr>
+          <p:cNvPr id="48" name="Text 23">
+            <a:extLst>
+              <a:ext uri="{FF2B5EF4-FFF2-40B4-BE49-F238E27FC236}">
+                <a16:creationId xmlns:a16="http://schemas.microsoft.com/office/drawing/2014/main" id="{2794847E-D14D-2618-2422-890B9733E2B1}"/>
+              </a:ext>
+            </a:extLst>
+          </p:cNvPr>
+          <p:cNvSpPr txBox="1"/>
+          <p:nvPr/>
+        </p:nvSpPr>
+        <p:spPr>
+          <a:xfrm>
+            <a:off x="9982199" y="5878068"/>
+            <a:ext cx="1237489" cy="941832"/>
+          </a:xfrm>
+          <a:prstGeom prst="rect">
+            <a:avLst/>
+          </a:prstGeom>
+          <a:noFill/>
+          <a:ln/>
+        </p:spPr>
+        <p:txBody>
+          <a:bodyPr wrap="square" lIns="635" tIns="635" rIns="635" bIns="635" rtlCol="0" anchor="ctr"/>
+          <a:lstStyle/>
+          <a:p>
+            <a:pPr marL="0" indent="0" algn="ctr">
+              <a:buNone/>
+            </a:pPr>
+            <a:r>
+              <a:rPr lang="en-US" sz="1400" b="1" dirty="0">
+                <a:solidFill>
+                  <a:srgbClr val="0B2545"/>
+                </a:solidFill>
+                <a:latin typeface="Calibri" pitchFamily="34" charset="0"/>
+                <a:ea typeface="Calibri" pitchFamily="34" charset="-122"/>
+                <a:cs typeface="Calibri" pitchFamily="34" charset="-120"/>
+              </a:rPr>
+              <a:t>Risk &amp; Safety Agent</a:t>
+            </a:r>
+            <a:endParaRPr lang="en-US" sz="1400" dirty="0"/>
+          </a:p>
+        </p:txBody>
+      </p:sp>
+      <p:sp>
+        <p:nvSpPr>
+          <p:cNvPr id="50" name="Shape 25">
+            <a:extLst>
+              <a:ext uri="{FF2B5EF4-FFF2-40B4-BE49-F238E27FC236}">
+                <a16:creationId xmlns:a16="http://schemas.microsoft.com/office/drawing/2014/main" id="{703A86B8-93DF-389B-4A99-B63483767D6E}"/>
+              </a:ext>
+            </a:extLst>
+          </p:cNvPr>
+          <p:cNvSpPr/>
+          <p:nvPr/>
+        </p:nvSpPr>
+        <p:spPr>
+          <a:xfrm>
+            <a:off x="11728703" y="5878068"/>
+            <a:ext cx="1237489" cy="941832"/>
+          </a:xfrm>
+          <a:prstGeom prst="roundRect">
+            <a:avLst>
+              <a:gd name="adj" fmla="val 8000"/>
+            </a:avLst>
+          </a:prstGeom>
+          <a:solidFill>
+            <a:srgbClr val="EAF1F8"/>
+          </a:solidFill>
+          <a:ln w="15875">
+            <a:solidFill>
+              <a:srgbClr val="0B2545"/>
+            </a:solidFill>
+            <a:prstDash val="solid"/>
+          </a:ln>
+        </p:spPr>
+      </p:sp>
+      <p:sp>
+        <p:nvSpPr>
+          <p:cNvPr id="51" name="Text 26">
+            <a:extLst>
+              <a:ext uri="{FF2B5EF4-FFF2-40B4-BE49-F238E27FC236}">
+                <a16:creationId xmlns:a16="http://schemas.microsoft.com/office/drawing/2014/main" id="{7E925845-4D5D-1F29-6B51-B793E873179A}"/>
+              </a:ext>
+            </a:extLst>
+          </p:cNvPr>
+          <p:cNvSpPr txBox="1"/>
+          <p:nvPr/>
+        </p:nvSpPr>
+        <p:spPr>
+          <a:xfrm>
+            <a:off x="11728703" y="5878068"/>
+            <a:ext cx="1237489" cy="941832"/>
+          </a:xfrm>
+          <a:prstGeom prst="rect">
+            <a:avLst/>
+          </a:prstGeom>
+          <a:noFill/>
+          <a:ln/>
+        </p:spPr>
+        <p:txBody>
+          <a:bodyPr wrap="square" lIns="635" tIns="635" rIns="635" bIns="635" rtlCol="0" anchor="ctr"/>
+          <a:lstStyle/>
+          <a:p>
+            <a:pPr marL="0" indent="0" algn="ctr">
+              <a:buNone/>
+            </a:pPr>
+            <a:r>
+              <a:rPr lang="en-US" sz="1400" b="1" dirty="0">
+                <a:solidFill>
+                  <a:srgbClr val="0B2545"/>
+                </a:solidFill>
+                <a:latin typeface="Calibri" pitchFamily="34" charset="0"/>
+                <a:ea typeface="Calibri" pitchFamily="34" charset="-122"/>
+                <a:cs typeface="Calibri" pitchFamily="34" charset="-120"/>
+              </a:rPr>
+              <a:t>Route / Geospatial Analysis</a:t>
+            </a:r>
+            <a:endParaRPr lang="en-US" sz="1400" dirty="0"/>
+          </a:p>
+        </p:txBody>
+      </p:sp>
+      <p:sp>
+        <p:nvSpPr>
+          <p:cNvPr id="53" name="Shape 28">
+            <a:extLst>
+              <a:ext uri="{FF2B5EF4-FFF2-40B4-BE49-F238E27FC236}">
+                <a16:creationId xmlns:a16="http://schemas.microsoft.com/office/drawing/2014/main" id="{17698F12-B625-0110-1A88-5D233412BBA9}"/>
+              </a:ext>
+            </a:extLst>
+          </p:cNvPr>
+          <p:cNvSpPr/>
+          <p:nvPr/>
+        </p:nvSpPr>
+        <p:spPr>
+          <a:xfrm>
+            <a:off x="13475207" y="5878068"/>
+            <a:ext cx="1237489" cy="941832"/>
+          </a:xfrm>
+          <a:prstGeom prst="roundRect">
+            <a:avLst>
+              <a:gd name="adj" fmla="val 8000"/>
+            </a:avLst>
+          </a:prstGeom>
+          <a:solidFill>
+            <a:srgbClr val="EAF1F8"/>
+          </a:solidFill>
+          <a:ln w="15875">
+            <a:solidFill>
+              <a:srgbClr val="0B2545"/>
+            </a:solidFill>
+            <a:prstDash val="solid"/>
+          </a:ln>
+        </p:spPr>
+      </p:sp>
+      <p:sp>
+        <p:nvSpPr>
+          <p:cNvPr id="54" name="Text 29">
+            <a:extLst>
+              <a:ext uri="{FF2B5EF4-FFF2-40B4-BE49-F238E27FC236}">
+                <a16:creationId xmlns:a16="http://schemas.microsoft.com/office/drawing/2014/main" id="{8C73D871-F250-E377-8D98-751D90E8A70B}"/>
+              </a:ext>
+            </a:extLst>
+          </p:cNvPr>
+          <p:cNvSpPr txBox="1"/>
+          <p:nvPr/>
+        </p:nvSpPr>
+        <p:spPr>
+          <a:xfrm>
+            <a:off x="13475207" y="5878068"/>
+            <a:ext cx="1237489" cy="941832"/>
+          </a:xfrm>
+          <a:prstGeom prst="rect">
+            <a:avLst/>
+          </a:prstGeom>
+          <a:noFill/>
+          <a:ln/>
+        </p:spPr>
+        <p:txBody>
+          <a:bodyPr wrap="square" lIns="635" tIns="635" rIns="635" bIns="635" rtlCol="0" anchor="ctr"/>
+          <a:lstStyle/>
+          <a:p>
+            <a:pPr marL="0" indent="0" algn="ctr">
+              <a:buNone/>
+            </a:pPr>
+            <a:r>
+              <a:rPr lang="en-US" sz="1400" b="1" dirty="0">
+                <a:solidFill>
+                  <a:srgbClr val="0B2545"/>
+                </a:solidFill>
+                <a:latin typeface="Calibri" pitchFamily="34" charset="0"/>
+                <a:ea typeface="Calibri" pitchFamily="34" charset="-122"/>
+                <a:cs typeface="Calibri" pitchFamily="34" charset="-120"/>
+              </a:rPr>
+              <a:t>Synthesis Agent</a:t>
+            </a:r>
+            <a:endParaRPr lang="en-US" sz="1400" dirty="0"/>
+          </a:p>
+        </p:txBody>
+      </p:sp>
+      <p:sp>
+        <p:nvSpPr>
+          <p:cNvPr id="56" name="Shape 31">
+            <a:extLst>
+              <a:ext uri="{FF2B5EF4-FFF2-40B4-BE49-F238E27FC236}">
+                <a16:creationId xmlns:a16="http://schemas.microsoft.com/office/drawing/2014/main" id="{D535C588-A47D-96E1-4A88-9CAD74979D35}"/>
+              </a:ext>
+            </a:extLst>
+          </p:cNvPr>
+          <p:cNvSpPr/>
+          <p:nvPr/>
+        </p:nvSpPr>
+        <p:spPr>
+          <a:xfrm>
+            <a:off x="15221711" y="5878068"/>
+            <a:ext cx="1237489" cy="941832"/>
+          </a:xfrm>
+          <a:prstGeom prst="roundRect">
+            <a:avLst>
+              <a:gd name="adj" fmla="val 8000"/>
+            </a:avLst>
+          </a:prstGeom>
+          <a:solidFill>
+            <a:srgbClr val="EAF1F8"/>
+          </a:solidFill>
+          <a:ln w="15875">
+            <a:solidFill>
+              <a:srgbClr val="0B2545"/>
+            </a:solidFill>
+            <a:prstDash val="solid"/>
+          </a:ln>
+        </p:spPr>
+      </p:sp>
+      <p:sp>
+        <p:nvSpPr>
+          <p:cNvPr id="57" name="Text 32">
+            <a:extLst>
+              <a:ext uri="{FF2B5EF4-FFF2-40B4-BE49-F238E27FC236}">
+                <a16:creationId xmlns:a16="http://schemas.microsoft.com/office/drawing/2014/main" id="{B4C5DFF4-CC26-208E-D42B-3EE976C908F6}"/>
+              </a:ext>
+            </a:extLst>
+          </p:cNvPr>
+          <p:cNvSpPr txBox="1"/>
+          <p:nvPr/>
+        </p:nvSpPr>
+        <p:spPr>
+          <a:xfrm>
+            <a:off x="15221711" y="5878068"/>
+            <a:ext cx="1237489" cy="941832"/>
+          </a:xfrm>
+          <a:prstGeom prst="rect">
+            <a:avLst/>
+          </a:prstGeom>
+          <a:noFill/>
+          <a:ln/>
+        </p:spPr>
+        <p:txBody>
+          <a:bodyPr wrap="square" lIns="635" tIns="635" rIns="635" bIns="635" rtlCol="0" anchor="ctr"/>
+          <a:lstStyle/>
+          <a:p>
+            <a:pPr marL="0" indent="0" algn="ctr">
+              <a:buNone/>
+            </a:pPr>
+            <a:r>
+              <a:rPr lang="en-US" sz="1400" b="1" dirty="0">
+                <a:solidFill>
+                  <a:srgbClr val="0B2545"/>
+                </a:solidFill>
+                <a:latin typeface="Calibri" pitchFamily="34" charset="0"/>
+                <a:ea typeface="Calibri" pitchFamily="34" charset="-122"/>
+                <a:cs typeface="Calibri" pitchFamily="34" charset="-120"/>
+              </a:rPr>
+              <a:t>Explainable Decision</a:t>
+            </a:r>
+            <a:endParaRPr lang="en-US" sz="1400" dirty="0"/>
+          </a:p>
+        </p:txBody>
+      </p:sp>
+      <p:sp>
+        <p:nvSpPr>
+          <p:cNvPr id="59" name="Shape 34">
+            <a:extLst>
+              <a:ext uri="{FF2B5EF4-FFF2-40B4-BE49-F238E27FC236}">
+                <a16:creationId xmlns:a16="http://schemas.microsoft.com/office/drawing/2014/main" id="{0D502FEA-0ABA-D67B-11D3-F88D40626E25}"/>
+              </a:ext>
+            </a:extLst>
+          </p:cNvPr>
+          <p:cNvSpPr/>
+          <p:nvPr/>
+        </p:nvSpPr>
+        <p:spPr>
+          <a:xfrm>
+            <a:off x="16727039" y="5878073"/>
+            <a:ext cx="1259997" cy="941827"/>
+          </a:xfrm>
+          <a:prstGeom prst="roundRect">
+            <a:avLst>
+              <a:gd name="adj" fmla="val 8000"/>
+            </a:avLst>
+          </a:prstGeom>
+          <a:solidFill>
+            <a:srgbClr val="0E7C7B"/>
+          </a:solidFill>
+          <a:ln w="15875">
+            <a:solidFill>
+              <a:srgbClr val="0E7C7B"/>
+            </a:solidFill>
+            <a:prstDash val="solid"/>
+          </a:ln>
+        </p:spPr>
+        <p:txBody>
+          <a:bodyPr/>
+          <a:lstStyle/>
+          <a:p>
+            <a:endParaRPr lang="en-IN" dirty="0"/>
+          </a:p>
+        </p:txBody>
+      </p:sp>
+      <p:sp>
+        <p:nvSpPr>
+          <p:cNvPr id="60" name="Text 35">
+            <a:extLst>
+              <a:ext uri="{FF2B5EF4-FFF2-40B4-BE49-F238E27FC236}">
+                <a16:creationId xmlns:a16="http://schemas.microsoft.com/office/drawing/2014/main" id="{2435BBD5-187B-E3C5-FF43-5430B0345EE3}"/>
+              </a:ext>
+            </a:extLst>
+          </p:cNvPr>
+          <p:cNvSpPr txBox="1"/>
+          <p:nvPr/>
+        </p:nvSpPr>
+        <p:spPr>
+          <a:xfrm>
+            <a:off x="16885866" y="6041752"/>
+            <a:ext cx="976021" cy="713232"/>
+          </a:xfrm>
+          <a:prstGeom prst="rect">
+            <a:avLst/>
+          </a:prstGeom>
+          <a:noFill/>
+          <a:ln/>
+        </p:spPr>
+        <p:txBody>
+          <a:bodyPr wrap="square" lIns="635" tIns="635" rIns="635" bIns="635" rtlCol="0" anchor="ctr"/>
+          <a:lstStyle/>
+          <a:p>
+            <a:pPr marL="0" indent="0" algn="ctr">
+              <a:buNone/>
+            </a:pPr>
+            <a:r>
+              <a:rPr lang="en-US" sz="1400" b="1" dirty="0">
+                <a:solidFill>
+                  <a:srgbClr val="FFFFFF"/>
+                </a:solidFill>
+                <a:latin typeface="Calibri" pitchFamily="34" charset="0"/>
+                <a:ea typeface="Calibri" pitchFamily="34" charset="-122"/>
+                <a:cs typeface="Calibri" pitchFamily="34" charset="-120"/>
+              </a:rPr>
+              <a:t>Web / Map / Voice Response</a:t>
+            </a:r>
+            <a:endParaRPr lang="en-US" sz="1400" dirty="0"/>
+          </a:p>
+        </p:txBody>
+      </p:sp>
       <p:cxnSp>
         <p:nvCxnSpPr>
-          <p:cNvPr id="26" name="Straight Arrow Connector 25">
-            <a:extLst>
-              <a:ext uri="{FF2B5EF4-FFF2-40B4-BE49-F238E27FC236}">
-                <a16:creationId xmlns:a16="http://schemas.microsoft.com/office/drawing/2014/main" id="{2C2C011F-8F96-C7A4-E92A-3BB1AF5C4DDD}"/>
-              </a:ext>
-            </a:extLst>
-          </p:cNvPr>
-          <p:cNvCxnSpPr>
-            <a:stCxn id="20" idx="3"/>
-            <a:endCxn id="21" idx="1"/>
-          </p:cNvCxnSpPr>
+          <p:cNvPr id="62" name="Straight Arrow Connector 61">
+            <a:extLst>
+              <a:ext uri="{FF2B5EF4-FFF2-40B4-BE49-F238E27FC236}">
+                <a16:creationId xmlns:a16="http://schemas.microsoft.com/office/drawing/2014/main" id="{21C43DC1-C6B4-C3DA-3519-E5C286B379A8}"/>
+              </a:ext>
+            </a:extLst>
+          </p:cNvPr>
+          <p:cNvCxnSpPr/>
           <p:nvPr/>
         </p:nvCxnSpPr>
         <p:spPr>
-          <a:xfrm flipV="1">
-            <a:off x="12880363" y="2883703"/>
-            <a:ext cx="644285" cy="1"/>
+          <a:xfrm>
+            <a:off x="14249400" y="3646932"/>
+            <a:ext cx="0" cy="639548"/>
           </a:xfrm>
           <a:prstGeom prst="straightConnector1">
             <a:avLst/>
@@ -6454,28 +7119,31 @@
       </p:cxnSp>
       <p:cxnSp>
         <p:nvCxnSpPr>
-          <p:cNvPr id="29" name="Straight Arrow Connector 28">
-            <a:extLst>
-              <a:ext uri="{FF2B5EF4-FFF2-40B4-BE49-F238E27FC236}">
-                <a16:creationId xmlns:a16="http://schemas.microsoft.com/office/drawing/2014/main" id="{567292C6-0D3D-8B91-2A41-5EE525E97F46}"/>
+          <p:cNvPr id="64" name="Connector: Elbow 63">
+            <a:extLst>
+              <a:ext uri="{FF2B5EF4-FFF2-40B4-BE49-F238E27FC236}">
+                <a16:creationId xmlns:a16="http://schemas.microsoft.com/office/drawing/2014/main" id="{13AF843F-D848-EFA7-219F-210EEAFFF23E}"/>
               </a:ext>
             </a:extLst>
           </p:cNvPr>
           <p:cNvCxnSpPr>
-            <a:stCxn id="21" idx="3"/>
-            <a:endCxn id="19" idx="1"/>
+            <a:stCxn id="35" idx="0"/>
+            <a:endCxn id="40" idx="0"/>
           </p:cNvCxnSpPr>
           <p:nvPr/>
         </p:nvCxnSpPr>
         <p:spPr>
-          <a:xfrm>
-            <a:off x="15524898" y="2883703"/>
-            <a:ext cx="515130" cy="5679"/>
-          </a:xfrm>
-          <a:prstGeom prst="straightConnector1">
-            <a:avLst/>
+          <a:xfrm rot="5400000" flipH="1" flipV="1">
+            <a:off x="14336558" y="1744980"/>
+            <a:ext cx="12700" cy="5120640"/>
+          </a:xfrm>
+          <a:prstGeom prst="bentConnector3">
+            <a:avLst>
+              <a:gd name="adj1" fmla="val 3726764"/>
+            </a:avLst>
           </a:prstGeom>
           <a:ln>
+            <a:headEnd type="triangle"/>
             <a:tailEnd type="triangle"/>
           </a:ln>
         </p:spPr>
@@ -6496,23 +7164,23 @@
       </p:cxnSp>
       <p:cxnSp>
         <p:nvCxnSpPr>
-          <p:cNvPr id="31" name="Straight Arrow Connector 30">
-            <a:extLst>
-              <a:ext uri="{FF2B5EF4-FFF2-40B4-BE49-F238E27FC236}">
-                <a16:creationId xmlns:a16="http://schemas.microsoft.com/office/drawing/2014/main" id="{9C2430B4-0B96-BE7B-AE97-5DB337FB061C}"/>
+          <p:cNvPr id="68" name="Straight Arrow Connector 67">
+            <a:extLst>
+              <a:ext uri="{FF2B5EF4-FFF2-40B4-BE49-F238E27FC236}">
+                <a16:creationId xmlns:a16="http://schemas.microsoft.com/office/drawing/2014/main" id="{A490BCD5-53FF-81CB-B6DC-4A7B98F2CA14}"/>
               </a:ext>
             </a:extLst>
           </p:cNvPr>
           <p:cNvCxnSpPr>
-            <a:stCxn id="19" idx="2"/>
-            <a:endCxn id="22" idx="0"/>
+            <a:stCxn id="48" idx="3"/>
+            <a:endCxn id="51" idx="1"/>
           </p:cNvCxnSpPr>
           <p:nvPr/>
         </p:nvCxnSpPr>
         <p:spPr>
           <a:xfrm>
-            <a:off x="17040153" y="3979994"/>
-            <a:ext cx="11243" cy="811689"/>
+            <a:off x="11219688" y="6348984"/>
+            <a:ext cx="509015" cy="0"/>
           </a:xfrm>
           <a:prstGeom prst="straightConnector1">
             <a:avLst/>
@@ -6538,22 +7206,23 @@
       </p:cxnSp>
       <p:cxnSp>
         <p:nvCxnSpPr>
-          <p:cNvPr id="34" name="Straight Arrow Connector 33">
-            <a:extLst>
-              <a:ext uri="{FF2B5EF4-FFF2-40B4-BE49-F238E27FC236}">
-                <a16:creationId xmlns:a16="http://schemas.microsoft.com/office/drawing/2014/main" id="{15AC548C-46F3-E918-6D70-55CF55355097}"/>
+          <p:cNvPr id="71" name="Straight Arrow Connector 70">
+            <a:extLst>
+              <a:ext uri="{FF2B5EF4-FFF2-40B4-BE49-F238E27FC236}">
+                <a16:creationId xmlns:a16="http://schemas.microsoft.com/office/drawing/2014/main" id="{883EA8D2-A982-A5EA-2274-A71F751B193E}"/>
               </a:ext>
             </a:extLst>
           </p:cNvPr>
           <p:cNvCxnSpPr>
-            <a:stCxn id="22" idx="1"/>
+            <a:stCxn id="51" idx="3"/>
+            <a:endCxn id="54" idx="1"/>
           </p:cNvCxnSpPr>
           <p:nvPr/>
         </p:nvCxnSpPr>
         <p:spPr>
-          <a:xfrm flipH="1" flipV="1">
-            <a:off x="15524898" y="5882295"/>
-            <a:ext cx="526373" cy="1"/>
+          <a:xfrm>
+            <a:off x="12966192" y="6348984"/>
+            <a:ext cx="509015" cy="0"/>
           </a:xfrm>
           <a:prstGeom prst="straightConnector1">
             <a:avLst/>
@@ -6579,23 +7248,23 @@
       </p:cxnSp>
       <p:cxnSp>
         <p:nvCxnSpPr>
-          <p:cNvPr id="36" name="Straight Arrow Connector 35">
-            <a:extLst>
-              <a:ext uri="{FF2B5EF4-FFF2-40B4-BE49-F238E27FC236}">
-                <a16:creationId xmlns:a16="http://schemas.microsoft.com/office/drawing/2014/main" id="{D75A1C73-39B3-C5D0-05E1-2CA42BC053E5}"/>
+          <p:cNvPr id="84" name="Straight Arrow Connector 83">
+            <a:extLst>
+              <a:ext uri="{FF2B5EF4-FFF2-40B4-BE49-F238E27FC236}">
+                <a16:creationId xmlns:a16="http://schemas.microsoft.com/office/drawing/2014/main" id="{ED1D0EE3-A9CB-FD4B-6ADE-3A8A13C74BF2}"/>
               </a:ext>
             </a:extLst>
           </p:cNvPr>
           <p:cNvCxnSpPr>
-            <a:stCxn id="23" idx="1"/>
-            <a:endCxn id="24" idx="3"/>
+            <a:stCxn id="54" idx="3"/>
+            <a:endCxn id="57" idx="1"/>
           </p:cNvCxnSpPr>
           <p:nvPr/>
         </p:nvCxnSpPr>
         <p:spPr>
-          <a:xfrm flipH="1">
-            <a:off x="12926037" y="5881688"/>
-            <a:ext cx="667537" cy="0"/>
+          <a:xfrm>
+            <a:off x="14712696" y="6348984"/>
+            <a:ext cx="509015" cy="0"/>
           </a:xfrm>
           <a:prstGeom prst="straightConnector1">
             <a:avLst/>
@@ -6619,38 +7288,290 @@
           </a:fontRef>
         </p:style>
       </p:cxnSp>
-      <p:sp>
-        <p:nvSpPr>
-          <p:cNvPr id="15" name="TextBox 14">
-            <a:extLst>
-              <a:ext uri="{FF2B5EF4-FFF2-40B4-BE49-F238E27FC236}">
-                <a16:creationId xmlns:a16="http://schemas.microsoft.com/office/drawing/2014/main" id="{3C4B1F31-1BB9-3F3E-E231-56E5CE422946}"/>
-              </a:ext>
-            </a:extLst>
-          </p:cNvPr>
-          <p:cNvSpPr txBox="1"/>
-          <p:nvPr/>
-        </p:nvSpPr>
-        <p:spPr>
-          <a:xfrm>
-            <a:off x="5521486" y="8177150"/>
-            <a:ext cx="3406201" cy="1200329"/>
-          </a:xfrm>
-          <a:prstGeom prst="rect">
-            <a:avLst/>
-          </a:prstGeom>
-          <a:noFill/>
-        </p:spPr>
-        <p:txBody>
-          <a:bodyPr wrap="square" rtlCol="0">
-            <a:spAutoFit/>
-          </a:bodyPr>
-          <a:lstStyle/>
-          <a:p>
-            <a:r>
-              <a:rPr lang="en-IN" sz="2400" dirty="0"/>
-              <a:t>Uses AI to automate data analysis and reduce manual effort.</a:t>
-            </a:r>
+      <p:cxnSp>
+        <p:nvCxnSpPr>
+          <p:cNvPr id="87" name="Straight Arrow Connector 86">
+            <a:extLst>
+              <a:ext uri="{FF2B5EF4-FFF2-40B4-BE49-F238E27FC236}">
+                <a16:creationId xmlns:a16="http://schemas.microsoft.com/office/drawing/2014/main" id="{127F6C85-C144-F838-47C7-B07BF71F9E95}"/>
+              </a:ext>
+            </a:extLst>
+          </p:cNvPr>
+          <p:cNvCxnSpPr>
+            <a:stCxn id="57" idx="3"/>
+            <a:endCxn id="59" idx="1"/>
+          </p:cNvCxnSpPr>
+          <p:nvPr/>
+        </p:nvCxnSpPr>
+        <p:spPr>
+          <a:xfrm>
+            <a:off x="16459200" y="6348984"/>
+            <a:ext cx="267839" cy="3"/>
+          </a:xfrm>
+          <a:prstGeom prst="straightConnector1">
+            <a:avLst/>
+          </a:prstGeom>
+          <a:ln>
+            <a:tailEnd type="triangle"/>
+          </a:ln>
+        </p:spPr>
+        <p:style>
+          <a:lnRef idx="3">
+            <a:schemeClr val="dk1"/>
+          </a:lnRef>
+          <a:fillRef idx="0">
+            <a:schemeClr val="dk1"/>
+          </a:fillRef>
+          <a:effectRef idx="2">
+            <a:schemeClr val="dk1"/>
+          </a:effectRef>
+          <a:fontRef idx="minor">
+            <a:schemeClr val="tx1"/>
+          </a:fontRef>
+        </p:style>
+      </p:cxnSp>
+      <p:cxnSp>
+        <p:nvCxnSpPr>
+          <p:cNvPr id="96" name="Straight Connector 95">
+            <a:extLst>
+              <a:ext uri="{FF2B5EF4-FFF2-40B4-BE49-F238E27FC236}">
+                <a16:creationId xmlns:a16="http://schemas.microsoft.com/office/drawing/2014/main" id="{A89D1C02-5685-34B5-E239-67053AA8D4AD}"/>
+              </a:ext>
+            </a:extLst>
+          </p:cNvPr>
+          <p:cNvCxnSpPr>
+            <a:cxnSpLocks/>
+            <a:stCxn id="35" idx="2"/>
+          </p:cNvCxnSpPr>
+          <p:nvPr/>
+        </p:nvCxnSpPr>
+        <p:spPr>
+          <a:xfrm>
+            <a:off x="11776238" y="4964582"/>
+            <a:ext cx="12700" cy="344015"/>
+          </a:xfrm>
+          <a:prstGeom prst="line">
+            <a:avLst/>
+          </a:prstGeom>
+        </p:spPr>
+        <p:style>
+          <a:lnRef idx="3">
+            <a:schemeClr val="dk1"/>
+          </a:lnRef>
+          <a:fillRef idx="0">
+            <a:schemeClr val="dk1"/>
+          </a:fillRef>
+          <a:effectRef idx="2">
+            <a:schemeClr val="dk1"/>
+          </a:effectRef>
+          <a:fontRef idx="minor">
+            <a:schemeClr val="tx1"/>
+          </a:fontRef>
+        </p:style>
+      </p:cxnSp>
+      <p:cxnSp>
+        <p:nvCxnSpPr>
+          <p:cNvPr id="97" name="Straight Connector 96">
+            <a:extLst>
+              <a:ext uri="{FF2B5EF4-FFF2-40B4-BE49-F238E27FC236}">
+                <a16:creationId xmlns:a16="http://schemas.microsoft.com/office/drawing/2014/main" id="{93EB4012-1CBD-823B-1C91-446A42F35409}"/>
+              </a:ext>
+            </a:extLst>
+          </p:cNvPr>
+          <p:cNvCxnSpPr>
+            <a:cxnSpLocks/>
+          </p:cNvCxnSpPr>
+          <p:nvPr/>
+        </p:nvCxnSpPr>
+        <p:spPr>
+          <a:xfrm>
+            <a:off x="14319250" y="4973765"/>
+            <a:ext cx="0" cy="542156"/>
+          </a:xfrm>
+          <a:prstGeom prst="line">
+            <a:avLst/>
+          </a:prstGeom>
+        </p:spPr>
+        <p:style>
+          <a:lnRef idx="3">
+            <a:schemeClr val="dk1"/>
+          </a:lnRef>
+          <a:fillRef idx="0">
+            <a:schemeClr val="dk1"/>
+          </a:fillRef>
+          <a:effectRef idx="2">
+            <a:schemeClr val="dk1"/>
+          </a:effectRef>
+          <a:fontRef idx="minor">
+            <a:schemeClr val="tx1"/>
+          </a:fontRef>
+        </p:style>
+      </p:cxnSp>
+      <p:cxnSp>
+        <p:nvCxnSpPr>
+          <p:cNvPr id="99" name="Straight Connector 98">
+            <a:extLst>
+              <a:ext uri="{FF2B5EF4-FFF2-40B4-BE49-F238E27FC236}">
+                <a16:creationId xmlns:a16="http://schemas.microsoft.com/office/drawing/2014/main" id="{4AF65187-EB47-A23E-A271-39B8F1744FDE}"/>
+              </a:ext>
+            </a:extLst>
+          </p:cNvPr>
+          <p:cNvCxnSpPr>
+            <a:cxnSpLocks/>
+          </p:cNvCxnSpPr>
+          <p:nvPr/>
+        </p:nvCxnSpPr>
+        <p:spPr>
+          <a:xfrm>
+            <a:off x="16982532" y="4973765"/>
+            <a:ext cx="0" cy="321276"/>
+          </a:xfrm>
+          <a:prstGeom prst="line">
+            <a:avLst/>
+          </a:prstGeom>
+        </p:spPr>
+        <p:style>
+          <a:lnRef idx="3">
+            <a:schemeClr val="dk1"/>
+          </a:lnRef>
+          <a:fillRef idx="0">
+            <a:schemeClr val="dk1"/>
+          </a:fillRef>
+          <a:effectRef idx="2">
+            <a:schemeClr val="dk1"/>
+          </a:effectRef>
+          <a:fontRef idx="minor">
+            <a:schemeClr val="tx1"/>
+          </a:fontRef>
+        </p:style>
+      </p:cxnSp>
+      <p:cxnSp>
+        <p:nvCxnSpPr>
+          <p:cNvPr id="105" name="Straight Connector 104">
+            <a:extLst>
+              <a:ext uri="{FF2B5EF4-FFF2-40B4-BE49-F238E27FC236}">
+                <a16:creationId xmlns:a16="http://schemas.microsoft.com/office/drawing/2014/main" id="{13887149-0918-A345-5D34-1B8A91A50DBE}"/>
+              </a:ext>
+            </a:extLst>
+          </p:cNvPr>
+          <p:cNvCxnSpPr/>
+          <p:nvPr/>
+        </p:nvCxnSpPr>
+        <p:spPr>
+          <a:xfrm>
+            <a:off x="11782588" y="5295900"/>
+            <a:ext cx="5199944" cy="0"/>
+          </a:xfrm>
+          <a:prstGeom prst="line">
+            <a:avLst/>
+          </a:prstGeom>
+        </p:spPr>
+        <p:style>
+          <a:lnRef idx="3">
+            <a:schemeClr val="dk1"/>
+          </a:lnRef>
+          <a:fillRef idx="0">
+            <a:schemeClr val="dk1"/>
+          </a:fillRef>
+          <a:effectRef idx="2">
+            <a:schemeClr val="dk1"/>
+          </a:effectRef>
+          <a:fontRef idx="minor">
+            <a:schemeClr val="tx1"/>
+          </a:fontRef>
+        </p:style>
+      </p:cxnSp>
+      <p:cxnSp>
+        <p:nvCxnSpPr>
+          <p:cNvPr id="116" name="Connector: Elbow 115">
+            <a:extLst>
+              <a:ext uri="{FF2B5EF4-FFF2-40B4-BE49-F238E27FC236}">
+                <a16:creationId xmlns:a16="http://schemas.microsoft.com/office/drawing/2014/main" id="{6CC6ADA5-5A9B-824D-2302-C460ED4FECFF}"/>
+              </a:ext>
+            </a:extLst>
+          </p:cNvPr>
+          <p:cNvCxnSpPr>
+            <a:cxnSpLocks/>
+            <a:endCxn id="48" idx="0"/>
+          </p:cNvCxnSpPr>
+          <p:nvPr/>
+        </p:nvCxnSpPr>
+        <p:spPr>
+          <a:xfrm rot="10800000" flipV="1">
+            <a:off x="10600945" y="5515922"/>
+            <a:ext cx="3735615" cy="362146"/>
+          </a:xfrm>
+          <a:prstGeom prst="bentConnector2">
+            <a:avLst/>
+          </a:prstGeom>
+          <a:ln>
+            <a:tailEnd type="triangle"/>
+          </a:ln>
+        </p:spPr>
+        <p:style>
+          <a:lnRef idx="3">
+            <a:schemeClr val="dk1"/>
+          </a:lnRef>
+          <a:fillRef idx="0">
+            <a:schemeClr val="dk1"/>
+          </a:fillRef>
+          <a:effectRef idx="2">
+            <a:schemeClr val="dk1"/>
+          </a:effectRef>
+          <a:fontRef idx="minor">
+            <a:schemeClr val="tx1"/>
+          </a:fontRef>
+        </p:style>
+      </p:cxnSp>
+      <p:sp>
+        <p:nvSpPr>
+          <p:cNvPr id="120" name="Oval 119">
+            <a:extLst>
+              <a:ext uri="{FF2B5EF4-FFF2-40B4-BE49-F238E27FC236}">
+                <a16:creationId xmlns:a16="http://schemas.microsoft.com/office/drawing/2014/main" id="{F0ECBD57-5EE2-DB48-8354-D1365A7E6D22}"/>
+              </a:ext>
+            </a:extLst>
+          </p:cNvPr>
+          <p:cNvSpPr/>
+          <p:nvPr/>
+        </p:nvSpPr>
+        <p:spPr>
+          <a:xfrm>
+            <a:off x="14217840" y="5180098"/>
+            <a:ext cx="202819" cy="193861"/>
+          </a:xfrm>
+          <a:prstGeom prst="ellipse">
+            <a:avLst/>
+          </a:prstGeom>
+          <a:solidFill>
+            <a:schemeClr val="tx1"/>
+          </a:solidFill>
+          <a:ln>
+            <a:noFill/>
+          </a:ln>
+        </p:spPr>
+        <p:style>
+          <a:lnRef idx="2">
+            <a:schemeClr val="accent1">
+              <a:shade val="15000"/>
+            </a:schemeClr>
+          </a:lnRef>
+          <a:fillRef idx="1">
+            <a:schemeClr val="accent1"/>
+          </a:fillRef>
+          <a:effectRef idx="0">
+            <a:schemeClr val="accent1"/>
+          </a:effectRef>
+          <a:fontRef idx="minor">
+            <a:schemeClr val="lt1"/>
+          </a:fontRef>
+        </p:style>
+        <p:txBody>
+          <a:bodyPr rtlCol="0" anchor="ctr"/>
+          <a:lstStyle/>
+          <a:p>
+            <a:pPr algn="ctr"/>
+            <a:endParaRPr lang="en-IN"/>
           </a:p>
         </p:txBody>
       </p:sp>
@@ -6699,7 +7620,7 @@
         <p:spPr>
           <a:xfrm>
             <a:off x="594854" y="1632676"/>
-            <a:ext cx="17388346" cy="7815263"/>
+            <a:ext cx="17388346" cy="7520849"/>
           </a:xfrm>
           <a:prstGeom prst="roundRect">
             <a:avLst>
@@ -11947,8 +12868,8 @@
         </p:nvSpPr>
         <p:spPr>
           <a:xfrm>
-            <a:off x="1172502" y="9578217"/>
-            <a:ext cx="16220363" cy="591256"/>
+            <a:off x="1172502" y="9200444"/>
+            <a:ext cx="16810698" cy="591256"/>
           </a:xfrm>
           <a:prstGeom prst="rect">
             <a:avLst/>
@@ -11971,9 +12892,144 @@
                 <a:ea typeface="Calibri" pitchFamily="34" charset="-122"/>
                 <a:cs typeface="Calibri" pitchFamily="34" charset="-120"/>
               </a:rPr>
-              <a:t>Flow:  ① Frontend → ② Backend + MongoDB → ③ Model Orchestration (pulls context from Memory Layer) → Memory Layer ↔ llms models → ④ Output Execution in sandbox → result returns to Backend → Frontend. </a:t>
+              <a:t>Flow:  ① </a:t>
+            </a:r>
+            <a:r>
+              <a:rPr lang="en-IN" dirty="0"/>
+              <a:t>User Query</a:t>
+            </a:r>
+            <a:r>
+              <a:rPr lang="en-US" dirty="0">
+                <a:latin typeface="Calibri" pitchFamily="34" charset="0"/>
+                <a:ea typeface="Calibri" pitchFamily="34" charset="-122"/>
+                <a:cs typeface="Calibri" pitchFamily="34" charset="-120"/>
+              </a:rPr>
+              <a:t> → ② </a:t>
+            </a:r>
+            <a:r>
+              <a:rPr lang="en-IN" dirty="0"/>
+              <a:t>Planner Agent</a:t>
+            </a:r>
+            <a:r>
+              <a:rPr lang="en-US" dirty="0">
+                <a:latin typeface="Calibri" pitchFamily="34" charset="0"/>
+                <a:ea typeface="Calibri" pitchFamily="34" charset="-122"/>
+                <a:cs typeface="Calibri" pitchFamily="34" charset="-120"/>
+              </a:rPr>
+              <a:t>→ ③ </a:t>
+            </a:r>
+            <a:r>
+              <a:rPr lang="en-IN" dirty="0"/>
+              <a:t>Parallel Specialist Agents</a:t>
+            </a:r>
+            <a:r>
+              <a:rPr lang="en-US" dirty="0">
+                <a:latin typeface="Calibri" pitchFamily="34" charset="0"/>
+                <a:ea typeface="Calibri" pitchFamily="34" charset="-122"/>
+                <a:cs typeface="Calibri" pitchFamily="34" charset="-120"/>
+              </a:rPr>
+              <a:t> → </a:t>
+            </a:r>
+            <a:r>
+              <a:rPr lang="en-IN" dirty="0"/>
+              <a:t>Data Validation</a:t>
+            </a:r>
+            <a:r>
+              <a:rPr lang="en-US" dirty="0">
+                <a:latin typeface="Calibri" pitchFamily="34" charset="0"/>
+                <a:ea typeface="Calibri" pitchFamily="34" charset="-122"/>
+                <a:cs typeface="Calibri" pitchFamily="34" charset="-120"/>
+              </a:rPr>
+              <a:t>↔ </a:t>
+            </a:r>
+            <a:r>
+              <a:rPr lang="en-IN" dirty="0"/>
+              <a:t>Risk/Safety Agent</a:t>
+            </a:r>
+            <a:r>
+              <a:rPr lang="en-US" dirty="0">
+                <a:latin typeface="Calibri" pitchFamily="34" charset="0"/>
+                <a:ea typeface="Calibri" pitchFamily="34" charset="-122"/>
+                <a:cs typeface="Calibri" pitchFamily="34" charset="-120"/>
+              </a:rPr>
+              <a:t>→ ④ </a:t>
+            </a:r>
+            <a:r>
+              <a:rPr lang="en-IN" dirty="0"/>
+              <a:t>Geo/Route Agent</a:t>
+            </a:r>
+            <a:r>
+              <a:rPr lang="en-US" dirty="0">
+                <a:latin typeface="Calibri" pitchFamily="34" charset="0"/>
+                <a:ea typeface="Calibri" pitchFamily="34" charset="-122"/>
+                <a:cs typeface="Calibri" pitchFamily="34" charset="-120"/>
+              </a:rPr>
+              <a:t>→ </a:t>
+            </a:r>
+            <a:r>
+              <a:rPr lang="en-IN" dirty="0"/>
+              <a:t>Synthesis Agent</a:t>
+            </a:r>
+            <a:r>
+              <a:rPr lang="en-US" dirty="0">
+                <a:latin typeface="Calibri" pitchFamily="34" charset="0"/>
+                <a:ea typeface="Calibri" pitchFamily="34" charset="-122"/>
+                <a:cs typeface="Calibri" pitchFamily="34" charset="-120"/>
+              </a:rPr>
+              <a:t>→ </a:t>
+            </a:r>
+            <a:r>
+              <a:rPr lang="en-IN" dirty="0"/>
+              <a:t>Explainable Answer</a:t>
+            </a:r>
+            <a:r>
+              <a:rPr lang="en-US" dirty="0">
+                <a:latin typeface="Calibri" pitchFamily="34" charset="0"/>
+                <a:ea typeface="Calibri" pitchFamily="34" charset="-122"/>
+                <a:cs typeface="Calibri" pitchFamily="34" charset="-120"/>
+              </a:rPr>
+              <a:t>. </a:t>
             </a:r>
             <a:endParaRPr lang="en-US" sz="1600" dirty="0"/>
+          </a:p>
+        </p:txBody>
+      </p:sp>
+      <p:sp>
+        <p:nvSpPr>
+          <p:cNvPr id="12" name="TextBox 11">
+            <a:extLst>
+              <a:ext uri="{FF2B5EF4-FFF2-40B4-BE49-F238E27FC236}">
+                <a16:creationId xmlns:a16="http://schemas.microsoft.com/office/drawing/2014/main" id="{E6419AC2-728A-D152-074D-E3D2E54FF465}"/>
+              </a:ext>
+            </a:extLst>
+          </p:cNvPr>
+          <p:cNvSpPr txBox="1"/>
+          <p:nvPr/>
+        </p:nvSpPr>
+        <p:spPr>
+          <a:xfrm>
+            <a:off x="1132731" y="9590389"/>
+            <a:ext cx="12456034" cy="369332"/>
+          </a:xfrm>
+          <a:prstGeom prst="rect">
+            <a:avLst/>
+          </a:prstGeom>
+          <a:noFill/>
+        </p:spPr>
+        <p:txBody>
+          <a:bodyPr wrap="square" rtlCol="0">
+            <a:spAutoFit/>
+          </a:bodyPr>
+          <a:lstStyle/>
+          <a:p>
+            <a:r>
+              <a:rPr lang="en-US" dirty="0"/>
+              <a:t>AGENTS : </a:t>
+            </a:r>
+            <a:r>
+              <a:rPr lang="en-IN" dirty="0"/>
+              <a:t>Ocean/PFZ Agent, Weather Agent, GIS/Geo Agent, Risk &amp; Safety Agent, Route Agent, Orchestrator/Synthesis Agent.</a:t>
+            </a:r>
           </a:p>
         </p:txBody>
       </p:sp>
@@ -16155,6 +17211,101 @@
           </a:p>
         </p:txBody>
       </p:sp>
+      <p:sp>
+        <p:nvSpPr>
+          <p:cNvPr id="4" name="TextBox 3">
+            <a:extLst>
+              <a:ext uri="{FF2B5EF4-FFF2-40B4-BE49-F238E27FC236}">
+                <a16:creationId xmlns:a16="http://schemas.microsoft.com/office/drawing/2014/main" id="{EF5338BF-CAEA-3FE1-805A-25C8C1E4ED78}"/>
+              </a:ext>
+            </a:extLst>
+          </p:cNvPr>
+          <p:cNvSpPr txBox="1"/>
+          <p:nvPr/>
+        </p:nvSpPr>
+        <p:spPr>
+          <a:xfrm>
+            <a:off x="914400" y="9665422"/>
+            <a:ext cx="6629400" cy="369332"/>
+          </a:xfrm>
+          <a:prstGeom prst="rect">
+            <a:avLst/>
+          </a:prstGeom>
+          <a:noFill/>
+        </p:spPr>
+        <p:txBody>
+          <a:bodyPr wrap="square" rtlCol="0">
+            <a:spAutoFit/>
+          </a:bodyPr>
+          <a:lstStyle/>
+          <a:p>
+            <a:r>
+              <a:rPr lang="en-IN" b="1" dirty="0"/>
+              <a:t>Prototype Link: </a:t>
+            </a:r>
+            <a:r>
+              <a:rPr lang="en-IN" b="1" dirty="0">
+                <a:solidFill>
+                  <a:srgbClr val="0000FF"/>
+                </a:solidFill>
+              </a:rPr>
+              <a:t>https://orca-frontend-55rq.onrender.com</a:t>
+            </a:r>
+          </a:p>
+        </p:txBody>
+      </p:sp>
+      <p:sp>
+        <p:nvSpPr>
+          <p:cNvPr id="7" name="Rectangle 6">
+            <a:extLst>
+              <a:ext uri="{FF2B5EF4-FFF2-40B4-BE49-F238E27FC236}">
+                <a16:creationId xmlns:a16="http://schemas.microsoft.com/office/drawing/2014/main" id="{9A2A18D4-2B13-7737-67D0-2E00764360EE}"/>
+              </a:ext>
+            </a:extLst>
+          </p:cNvPr>
+          <p:cNvSpPr/>
+          <p:nvPr/>
+        </p:nvSpPr>
+        <p:spPr>
+          <a:xfrm>
+            <a:off x="914400" y="9665422"/>
+            <a:ext cx="6172200" cy="430126"/>
+          </a:xfrm>
+          <a:prstGeom prst="rect">
+            <a:avLst/>
+          </a:prstGeom>
+          <a:noFill/>
+          <a:ln>
+            <a:solidFill>
+              <a:schemeClr val="tx1"/>
+            </a:solidFill>
+          </a:ln>
+        </p:spPr>
+        <p:style>
+          <a:lnRef idx="2">
+            <a:schemeClr val="accent1">
+              <a:shade val="15000"/>
+            </a:schemeClr>
+          </a:lnRef>
+          <a:fillRef idx="1">
+            <a:schemeClr val="accent1"/>
+          </a:fillRef>
+          <a:effectRef idx="0">
+            <a:schemeClr val="accent1"/>
+          </a:effectRef>
+          <a:fontRef idx="minor">
+            <a:schemeClr val="lt1"/>
+          </a:fontRef>
+        </p:style>
+        <p:txBody>
+          <a:bodyPr rtlCol="0" anchor="ctr"/>
+          <a:lstStyle/>
+          <a:p>
+            <a:pPr algn="ctr"/>
+            <a:endParaRPr lang="en-IN"/>
+          </a:p>
+        </p:txBody>
+      </p:sp>
     </p:spTree>
     <p:extLst>
       <p:ext uri="{BB962C8B-B14F-4D97-AF65-F5344CB8AC3E}">

</xml_diff>

<commit_message>
feat: auto wake-up Python AI services on frontend connect and server bootstrap
</commit_message>
<xml_diff>
--- a/SIH26176.pptx
+++ b/SIH26176.pptx
@@ -17225,7 +17225,7 @@
         </p:nvSpPr>
         <p:spPr>
           <a:xfrm>
-            <a:off x="914400" y="9665422"/>
+            <a:off x="914400" y="9352308"/>
             <a:ext cx="6629400" cy="369332"/>
           </a:xfrm>
           <a:prstGeom prst="rect">
@@ -17249,7 +17249,7 @@
                   <a:srgbClr val="0000FF"/>
                 </a:solidFill>
               </a:rPr>
-              <a:t>https://orca-frontend-55rq.onrender.com</a:t>
+              <a:t>https://orca-frontend-51u4.onrender.com/</a:t>
             </a:r>
           </a:p>
         </p:txBody>
@@ -17268,8 +17268,8 @@
         </p:nvSpPr>
         <p:spPr>
           <a:xfrm>
-            <a:off x="914400" y="9665422"/>
-            <a:ext cx="6172200" cy="430126"/>
+            <a:off x="914400" y="9352308"/>
+            <a:ext cx="6172200" cy="934692"/>
           </a:xfrm>
           <a:prstGeom prst="rect">
             <a:avLst/>
@@ -17303,6 +17303,49 @@
           <a:p>
             <a:pPr algn="ctr"/>
             <a:endParaRPr lang="en-IN"/>
+          </a:p>
+        </p:txBody>
+      </p:sp>
+      <p:sp>
+        <p:nvSpPr>
+          <p:cNvPr id="8" name="TextBox 7">
+            <a:extLst>
+              <a:ext uri="{FF2B5EF4-FFF2-40B4-BE49-F238E27FC236}">
+                <a16:creationId xmlns:a16="http://schemas.microsoft.com/office/drawing/2014/main" id="{796ECC01-71C1-CB1F-E992-5FCC48C71F4B}"/>
+              </a:ext>
+            </a:extLst>
+          </p:cNvPr>
+          <p:cNvSpPr txBox="1"/>
+          <p:nvPr/>
+        </p:nvSpPr>
+        <p:spPr>
+          <a:xfrm>
+            <a:off x="920522" y="9760471"/>
+            <a:ext cx="6629400" cy="369332"/>
+          </a:xfrm>
+          <a:prstGeom prst="rect">
+            <a:avLst/>
+          </a:prstGeom>
+          <a:noFill/>
+        </p:spPr>
+        <p:txBody>
+          <a:bodyPr wrap="square" rtlCol="0">
+            <a:spAutoFit/>
+          </a:bodyPr>
+          <a:lstStyle/>
+          <a:p>
+            <a:r>
+              <a:rPr lang="en-IN" b="1" dirty="0"/>
+              <a:t>GitHub: </a:t>
+            </a:r>
+            <a:r>
+              <a:rPr lang="en-IN" b="1" dirty="0">
+                <a:solidFill>
+                  <a:srgbClr val="0000FF"/>
+                </a:solidFill>
+              </a:rPr>
+              <a:t>https://github.com/avinash2005bharti/NEERDRISTHI</a:t>
+            </a:r>
           </a:p>
         </p:txBody>
       </p:sp>

</xml_diff>